<commit_message>
Update VT-01 Virtualization Introduction.pptx
</commit_message>
<xml_diff>
--- a/Slides/CSC6103/VT-01 Virtualization Introduction.pptx
+++ b/Slides/CSC6103/VT-01 Virtualization Introduction.pptx
@@ -7166,69 +7166,230 @@
         </p:nvSpPr>
         <p:spPr>
           <a:xfrm>
-            <a:off x="965200" y="844153"/>
-            <a:ext cx="7329714" cy="3671888"/>
+            <a:off x="840620" y="810286"/>
+            <a:ext cx="7462760" cy="3541581"/>
           </a:xfrm>
         </p:spPr>
         <p:txBody>
           <a:bodyPr/>
           <a:lstStyle/>
           <a:p>
-            <a:r>
-              <a:rPr lang="en-US" altLang="zh-TW" sz="2400" dirty="0">
-                <a:latin typeface="Times New Roman" panose="02020603050405020304" pitchFamily="18" charset="0"/>
-                <a:cs typeface="Times New Roman" panose="02020603050405020304" pitchFamily="18" charset="0"/>
-              </a:rPr>
-              <a:t>In their 1974 article "Formal Requirements for </a:t>
-            </a:r>
-            <a:r>
-              <a:rPr lang="en-US" altLang="zh-TW" sz="2400" dirty="0" err="1">
-                <a:latin typeface="Times New Roman" panose="02020603050405020304" pitchFamily="18" charset="0"/>
-                <a:cs typeface="Times New Roman" panose="02020603050405020304" pitchFamily="18" charset="0"/>
-              </a:rPr>
-              <a:t>Virtualizable</a:t>
-            </a:r>
-            <a:r>
-              <a:rPr lang="en-US" altLang="zh-TW" sz="2400" dirty="0">
-                <a:latin typeface="Times New Roman" panose="02020603050405020304" pitchFamily="18" charset="0"/>
-                <a:cs typeface="Times New Roman" panose="02020603050405020304" pitchFamily="18" charset="0"/>
-              </a:rPr>
-              <a:t> Third Generation Architectures" Gerald J. </a:t>
-            </a:r>
-            <a:r>
-              <a:rPr lang="en-US" altLang="zh-TW" sz="2400" dirty="0" err="1">
-                <a:latin typeface="Times New Roman" panose="02020603050405020304" pitchFamily="18" charset="0"/>
-                <a:cs typeface="Times New Roman" panose="02020603050405020304" pitchFamily="18" charset="0"/>
-              </a:rPr>
-              <a:t>Popek</a:t>
-            </a:r>
-            <a:r>
-              <a:rPr lang="en-US" altLang="zh-TW" sz="2400" dirty="0">
-                <a:latin typeface="Times New Roman" panose="02020603050405020304" pitchFamily="18" charset="0"/>
-                <a:cs typeface="Times New Roman" panose="02020603050405020304" pitchFamily="18" charset="0"/>
-              </a:rPr>
-              <a:t> and Robert P. Goldberg classified two types of hypervisor:</a:t>
-            </a:r>
-          </a:p>
-          <a:p>
-            <a:pPr lvl="1"/>
+            <a:pPr>
+              <a:spcBef>
+                <a:spcPts val="0"/>
+              </a:spcBef>
+            </a:pPr>
             <a:r>
               <a:rPr lang="en-US" altLang="zh-TW" sz="2000" dirty="0">
                 <a:latin typeface="Times New Roman" panose="02020603050405020304" pitchFamily="18" charset="0"/>
                 <a:cs typeface="Times New Roman" panose="02020603050405020304" pitchFamily="18" charset="0"/>
               </a:rPr>
-              <a:t>Type 1 hypervisor : Bare metal type</a:t>
-            </a:r>
-          </a:p>
-          <a:p>
-            <a:pPr lvl="1"/>
+              <a:t>In their 1974 article "Formal Requirements for </a:t>
+            </a:r>
+            <a:r>
+              <a:rPr lang="en-US" altLang="zh-TW" sz="2000" dirty="0" err="1">
+                <a:latin typeface="Times New Roman" panose="02020603050405020304" pitchFamily="18" charset="0"/>
+                <a:cs typeface="Times New Roman" panose="02020603050405020304" pitchFamily="18" charset="0"/>
+              </a:rPr>
+              <a:t>Virtualizable</a:t>
+            </a:r>
             <a:r>
               <a:rPr lang="en-US" altLang="zh-TW" sz="2000" dirty="0">
                 <a:latin typeface="Times New Roman" panose="02020603050405020304" pitchFamily="18" charset="0"/>
                 <a:cs typeface="Times New Roman" panose="02020603050405020304" pitchFamily="18" charset="0"/>
               </a:rPr>
-              <a:t>Type 2 hypervisor : Hosted type</a:t>
-            </a:r>
+              <a:t> Third Generation Architectures" Gerald J. </a:t>
+            </a:r>
+            <a:r>
+              <a:rPr lang="en-US" altLang="zh-TW" sz="2000" dirty="0" err="1">
+                <a:latin typeface="Times New Roman" panose="02020603050405020304" pitchFamily="18" charset="0"/>
+                <a:cs typeface="Times New Roman" panose="02020603050405020304" pitchFamily="18" charset="0"/>
+              </a:rPr>
+              <a:t>Popek</a:t>
+            </a:r>
+            <a:r>
+              <a:rPr lang="en-US" altLang="zh-TW" sz="2000" dirty="0">
+                <a:latin typeface="Times New Roman" panose="02020603050405020304" pitchFamily="18" charset="0"/>
+                <a:cs typeface="Times New Roman" panose="02020603050405020304" pitchFamily="18" charset="0"/>
+              </a:rPr>
+              <a:t> and Robert P. Goldberg classified two types of hypervisor</a:t>
+            </a:r>
+          </a:p>
+          <a:p>
+            <a:pPr lvl="1">
+              <a:spcBef>
+                <a:spcPts val="0"/>
+              </a:spcBef>
+            </a:pPr>
+            <a:r>
+              <a:rPr lang="en-US" altLang="zh-TW" sz="2000" dirty="0"/>
+              <a:t>Type 1 hypervisor (Bare metal type) </a:t>
+            </a:r>
+          </a:p>
+          <a:p>
+            <a:pPr lvl="2">
+              <a:spcBef>
+                <a:spcPts val="0"/>
+              </a:spcBef>
+            </a:pPr>
+            <a:r>
+              <a:rPr lang="en-US" dirty="0">
+                <a:solidFill>
+                  <a:srgbClr val="444444"/>
+                </a:solidFill>
+                <a:latin typeface="Times New Roman" panose="02020603050405020304" pitchFamily="18" charset="0"/>
+                <a:cs typeface="Times New Roman" panose="02020603050405020304" pitchFamily="18" charset="0"/>
+              </a:rPr>
+              <a:t>H</a:t>
+            </a:r>
+            <a:r>
+              <a:rPr lang="en-US" b="0" i="0" dirty="0">
+                <a:solidFill>
+                  <a:srgbClr val="444444"/>
+                </a:solidFill>
+                <a:effectLst/>
+                <a:latin typeface="Times New Roman" panose="02020603050405020304" pitchFamily="18" charset="0"/>
+                <a:cs typeface="Times New Roman" panose="02020603050405020304" pitchFamily="18" charset="0"/>
+              </a:rPr>
+              <a:t>ypervisors that run directly atop a physical system</a:t>
+            </a:r>
+            <a:r>
+              <a:rPr lang="en-US" dirty="0">
+                <a:latin typeface="Times New Roman" panose="02020603050405020304" pitchFamily="18" charset="0"/>
+                <a:cs typeface="Times New Roman" panose="02020603050405020304" pitchFamily="18" charset="0"/>
+              </a:rPr>
+              <a:t>, such as </a:t>
+            </a:r>
+            <a:r>
+              <a:rPr lang="en-US" b="0" i="0" dirty="0">
+                <a:solidFill>
+                  <a:srgbClr val="333333"/>
+                </a:solidFill>
+                <a:effectLst/>
+                <a:latin typeface="Times New Roman" panose="02020603050405020304" pitchFamily="18" charset="0"/>
+                <a:cs typeface="Times New Roman" panose="02020603050405020304" pitchFamily="18" charset="0"/>
+              </a:rPr>
+              <a:t>VMware </a:t>
+            </a:r>
+            <a:r>
+              <a:rPr lang="en-US" b="0" i="0" dirty="0" err="1">
+                <a:solidFill>
+                  <a:srgbClr val="333333"/>
+                </a:solidFill>
+                <a:effectLst/>
+                <a:latin typeface="Times New Roman" panose="02020603050405020304" pitchFamily="18" charset="0"/>
+                <a:cs typeface="Times New Roman" panose="02020603050405020304" pitchFamily="18" charset="0"/>
+              </a:rPr>
+              <a:t>ESXi</a:t>
+            </a:r>
+            <a:r>
+              <a:rPr lang="en-US" b="0" i="0" dirty="0">
+                <a:solidFill>
+                  <a:srgbClr val="333333"/>
+                </a:solidFill>
+                <a:effectLst/>
+                <a:latin typeface="Times New Roman" panose="02020603050405020304" pitchFamily="18" charset="0"/>
+                <a:cs typeface="Times New Roman" panose="02020603050405020304" pitchFamily="18" charset="0"/>
+              </a:rPr>
+              <a:t>, Microsoft Hyper-V, KVM, etc.</a:t>
+            </a:r>
+            <a:endParaRPr lang="en-US" altLang="zh-TW" dirty="0">
+              <a:latin typeface="Times New Roman" panose="02020603050405020304" pitchFamily="18" charset="0"/>
+              <a:cs typeface="Times New Roman" panose="02020603050405020304" pitchFamily="18" charset="0"/>
+            </a:endParaRPr>
+          </a:p>
+          <a:p>
+            <a:pPr lvl="1">
+              <a:spcBef>
+                <a:spcPts val="0"/>
+              </a:spcBef>
+            </a:pPr>
+            <a:r>
+              <a:rPr lang="en-US" altLang="zh-TW" sz="2000" dirty="0"/>
+              <a:t>Type 2 hypervisor (Hosted type) </a:t>
+            </a:r>
+          </a:p>
+          <a:p>
+            <a:pPr lvl="2">
+              <a:spcBef>
+                <a:spcPts val="0"/>
+              </a:spcBef>
+            </a:pPr>
+            <a:r>
+              <a:rPr lang="en-US" b="0" i="0" dirty="0">
+                <a:solidFill>
+                  <a:srgbClr val="35353A"/>
+                </a:solidFill>
+                <a:effectLst/>
+                <a:latin typeface="Times New Roman" panose="02020603050405020304" pitchFamily="18" charset="0"/>
+                <a:cs typeface="Times New Roman" panose="02020603050405020304" pitchFamily="18" charset="0"/>
+              </a:rPr>
+              <a:t>Hypervisor is a virtual machine </a:t>
+            </a:r>
+            <a:r>
+              <a:rPr lang="en-US" b="0" i="0" dirty="0">
+                <a:effectLst/>
+                <a:latin typeface="Times New Roman" panose="02020603050405020304" pitchFamily="18" charset="0"/>
+                <a:cs typeface="Times New Roman" panose="02020603050405020304" pitchFamily="18" charset="0"/>
+              </a:rPr>
+              <a:t>(</a:t>
+            </a:r>
+            <a:r>
+              <a:rPr lang="en-US" dirty="0">
+                <a:latin typeface="Times New Roman" panose="02020603050405020304" pitchFamily="18" charset="0"/>
+                <a:cs typeface="Times New Roman" panose="02020603050405020304" pitchFamily="18" charset="0"/>
+              </a:rPr>
+              <a:t>VM</a:t>
+            </a:r>
+            <a:r>
+              <a:rPr lang="en-US" b="0" i="0" dirty="0">
+                <a:effectLst/>
+                <a:latin typeface="Times New Roman" panose="02020603050405020304" pitchFamily="18" charset="0"/>
+                <a:cs typeface="Times New Roman" panose="02020603050405020304" pitchFamily="18" charset="0"/>
+              </a:rPr>
+              <a:t>) manager that is installed as a software application on an existing operating system (</a:t>
+            </a:r>
+            <a:r>
+              <a:rPr lang="en-US" dirty="0">
+                <a:latin typeface="Times New Roman" panose="02020603050405020304" pitchFamily="18" charset="0"/>
+                <a:cs typeface="Times New Roman" panose="02020603050405020304" pitchFamily="18" charset="0"/>
+              </a:rPr>
+              <a:t>OS</a:t>
+            </a:r>
+            <a:r>
+              <a:rPr lang="en-US" b="0" i="0" dirty="0">
+                <a:effectLst/>
+                <a:latin typeface="Times New Roman" panose="02020603050405020304" pitchFamily="18" charset="0"/>
+                <a:cs typeface="Times New Roman" panose="02020603050405020304" pitchFamily="18" charset="0"/>
+              </a:rPr>
+              <a:t>)</a:t>
+            </a:r>
+            <a:endParaRPr lang="en-US" altLang="zh-TW" dirty="0">
+              <a:latin typeface="Times New Roman" panose="02020603050405020304" pitchFamily="18" charset="0"/>
+              <a:cs typeface="Times New Roman" panose="02020603050405020304" pitchFamily="18" charset="0"/>
+            </a:endParaRPr>
+          </a:p>
+          <a:p>
+            <a:pPr lvl="3">
+              <a:spcBef>
+                <a:spcPts val="0"/>
+              </a:spcBef>
+            </a:pPr>
+            <a:r>
+              <a:rPr lang="en-US" sz="2000" b="0" i="0" dirty="0">
+                <a:solidFill>
+                  <a:srgbClr val="333333"/>
+                </a:solidFill>
+                <a:effectLst/>
+                <a:latin typeface="Times New Roman" panose="02020603050405020304" pitchFamily="18" charset="0"/>
+                <a:cs typeface="Times New Roman" panose="02020603050405020304" pitchFamily="18" charset="0"/>
+              </a:rPr>
+              <a:t>Oracle VM VirtualBox, VMware Workstation, Microsoft Virtual PC, etc.</a:t>
+            </a:r>
+            <a:endParaRPr lang="en-US" altLang="zh-TW" sz="2000" dirty="0">
+              <a:latin typeface="Times New Roman" panose="02020603050405020304" pitchFamily="18" charset="0"/>
+              <a:cs typeface="Times New Roman" panose="02020603050405020304" pitchFamily="18" charset="0"/>
+            </a:endParaRPr>
           </a:p>
         </p:txBody>
       </p:sp>
@@ -7998,8 +8159,8 @@
         </p:nvSpPr>
         <p:spPr>
           <a:xfrm>
-            <a:off x="798286" y="844153"/>
-            <a:ext cx="7779657" cy="3671888"/>
+            <a:off x="904618" y="844153"/>
+            <a:ext cx="7673325" cy="3671888"/>
           </a:xfrm>
         </p:spPr>
         <p:txBody>
@@ -17694,22 +17855,13 @@
           <a:p>
             <a:pPr algn="l"/>
             <a:r>
-              <a:rPr lang="en-US" altLang="zh-TW" sz="2000">
-                <a:latin typeface="Times New Roman" panose="02020603050405020304" pitchFamily="18" charset="0"/>
-                <a:ea typeface="新細明體" charset="-120"/>
-                <a:cs typeface="Times New Roman" panose="02020603050405020304" pitchFamily="18" charset="0"/>
-                <a:sym typeface="Lucida Grande" charset="0"/>
-              </a:rPr>
-              <a:t>Gartner predicted </a:t>
-            </a:r>
-            <a:r>
               <a:rPr lang="en-US" altLang="zh-TW" sz="2000" dirty="0">
                 <a:latin typeface="Times New Roman" panose="02020603050405020304" pitchFamily="18" charset="0"/>
                 <a:ea typeface="新細明體" charset="-120"/>
                 <a:cs typeface="Times New Roman" panose="02020603050405020304" pitchFamily="18" charset="0"/>
                 <a:sym typeface="Lucida Grande" charset="0"/>
               </a:rPr>
-              <a:t>that by 2012, more than </a:t>
+              <a:t>Gartner predicted that by 2012, more than </a:t>
             </a:r>
             <a:r>
               <a:rPr lang="en-US" altLang="zh-TW" sz="2000" dirty="0">

</xml_diff>